<commit_message>
Document 4 and deck: static-model results, balanced test set, augmentation ablation
Co-Authored-By: Claude Opus 5.5 <noreply@anthropic.com>
Claude-Session: https://claude.ai/code/session_015h4SwWvXQGuvs9F8VqDPvi
</commit_message>
<xml_diff>
--- a/docs/MalTwin_60pct_Evaluation.pptx
+++ b/docs/MalTwin_60pct_Evaluation.pptx
@@ -32,9 +32,10 @@
     <p:sldId id="280" r:id="rId26"/>
     <p:sldId id="281" r:id="rId27"/>
     <p:sldId id="282" r:id="rId28"/>
+    <p:sldId id="283" r:id="rId29"/>
   </p:sldIdLst>
   <p:notesMasterIdLst>
-    <p:notesMasterId r:id="rId29"/>
+    <p:notesMasterId r:id="rId30"/>
   </p:notesMasterIdLst>
   <p:sldSz cx="12192000" cy="6858000"/>
   <p:notesSz cx="6858000" cy="12192000"/>
@@ -133,17 +134,17 @@
   <p:extLst>
     <p:ext uri="{521415D9-36F7-43E2-AB2F-B90AF26B5E84}">
       <p14:sectionLst xmlns:p14="http://schemas.microsoft.com/office/powerpoint/2010/main">
-        <p14:section name="Title" id="{64fe277c-e583-1dee-f210-cf762d5021c8}">
+        <p14:section name="Title" id="{3df0f332-a6d1-fda2-5a0e-6c5a4e83db95}">
           <p14:sldIdLst>
             <p14:sldId id="256"/>
           </p14:sldIdLst>
         </p14:section>
-        <p14:section name="Introduction" id="{45dc10bf-dca3-5250-845a-f53e7edd3b0a}">
+        <p14:section name="Introduction" id="{5613ac2f-2377-6b94-967b-39457ec50b62}">
           <p14:sldIdLst>
             <p14:sldId id="257"/>
           </p14:sldIdLst>
         </p14:section>
-        <p14:section name="Changes since 30%" id="{748b5bea-87a5-75f8-9226-a9fe18c495ca}">
+        <p14:section name="Changes since 30%" id="{de51c16e-08d6-59f3-ee97-5f99d1423356}">
           <p14:sldIdLst>
             <p14:sldId id="258"/>
             <p14:sldId id="259"/>
@@ -152,7 +153,7 @@
             <p14:sldId id="262"/>
           </p14:sldIdLst>
         </p14:section>
-        <p14:section name="Implemented modules" id="{409d35e7-53c9-dd9c-1261-bc4843cedb79}">
+        <p14:section name="Implemented modules" id="{abb18a90-cf05-ead3-7eef-6eb8ec54bfdb}">
           <p14:sldIdLst>
             <p14:sldId id="263"/>
             <p14:sldId id="264"/>
@@ -162,14 +163,14 @@
             <p14:sldId id="268"/>
           </p14:sldIdLst>
         </p14:section>
-        <p14:section name="Testing" id="{f47ed746-437c-e496-d4f1-59bdc3846771}">
+        <p14:section name="Testing" id="{25c65a96-cb0f-b3a6-1fa8-d4503b37abbc}">
           <p14:sldIdLst>
             <p14:sldId id="269"/>
             <p14:sldId id="270"/>
             <p14:sldId id="271"/>
           </p14:sldIdLst>
         </p14:section>
-        <p14:section name="Automated testing" id="{4ed8cc1b-6b61-aefe-fb55-0e21e496c2f4}">
+        <p14:section name="Automated testing" id="{7f9c89a0-dd14-21e6-bf4a-c3803721237e}">
           <p14:sldIdLst>
             <p14:sldId id="272"/>
             <p14:sldId id="273"/>
@@ -178,22 +179,23 @@
             <p14:sldId id="276"/>
           </p14:sldIdLst>
         </p14:section>
-        <p14:section name="AI / ML techniques" id="{96a5b329-0705-68ed-f062-a844466c5dab}">
+        <p14:section name="AI / ML techniques" id="{ff75fd98-02e7-42c8-5876-146d77f3ffcd}">
           <p14:sldIdLst>
             <p14:sldId id="277"/>
             <p14:sldId id="278"/>
             <p14:sldId id="279"/>
+            <p14:sldId id="280"/>
           </p14:sldIdLst>
         </p14:section>
-        <p14:section name="Next steps" id="{7451edcd-23a1-746c-33a0-4757da8b73c0}">
+        <p14:section name="Next steps" id="{93c8d397-e7ce-6050-3b22-f24fd3e79970}">
           <p14:sldIdLst>
-            <p14:sldId id="280"/>
             <p14:sldId id="281"/>
+            <p14:sldId id="282"/>
           </p14:sldIdLst>
         </p14:section>
-        <p14:section name="Close" id="{f2aa51d8-5fec-ddd3-5ccd-1f9373046bcb}">
+        <p14:section name="Close" id="{622411cb-de7a-d5a8-180f-ae86ccb9273b}">
           <p14:sldIdLst>
-            <p14:sldId id="282"/>
+            <p14:sldId id="283"/>
           </p14:sldIdLst>
         </p14:section>
       </p14:sectionLst>
@@ -2296,6 +2298,94 @@
             <a:fld id="{F7021451-1387-4CA6-816F-3879F97B5CBC}" type="slidenum">
               <a:rPr lang="en-US"/>
               <a:t>27</a:t>
+            </a:fld>
+            <a:endParaRPr lang="en-US"/>
+          </a:p>
+        </p:txBody>
+      </p:sp>
+    </p:spTree>
+    <p:extLst>
+      <p:ext uri="{BB962C8B-B14F-4D97-AF65-F5344CB8AC3E}">
+        <p14:creationId xmlns:p14="http://schemas.microsoft.com/office/powerpoint/2010/main" val="1024086991"/>
+      </p:ext>
+    </p:extLst>
+  </p:cSld>
+  <p:clrMapOvr>
+    <a:masterClrMapping/>
+  </p:clrMapOvr>
+</p:notes>
+</file>
+
+<file path=ppt/notesSlides/notesSlide28.xml><?xml version="1.0" encoding="utf-8"?>
+<p:notes xmlns:a="http://schemas.openxmlformats.org/drawingml/2006/main" xmlns:r="http://schemas.openxmlformats.org/officeDocument/2006/relationships" xmlns:p="http://schemas.openxmlformats.org/presentationml/2006/main">
+  <p:cSld>
+    <p:spTree>
+      <p:nvGrpSpPr>
+        <p:cNvPr id="1" name=""/>
+        <p:cNvGrpSpPr/>
+        <p:nvPr/>
+      </p:nvGrpSpPr>
+      <p:grpSpPr>
+        <a:xfrm>
+          <a:off x="0" y="0"/>
+          <a:ext cx="0" cy="0"/>
+          <a:chOff x="0" y="0"/>
+          <a:chExt cx="0" cy="0"/>
+        </a:xfrm>
+      </p:grpSpPr>
+      <p:sp>
+        <p:nvSpPr>
+          <p:cNvPr id="2" name="Slide Image Placeholder 1"/>
+          <p:cNvSpPr>
+            <a:spLocks noGrp="1" noRot="1" noChangeAspect="1"/>
+          </p:cNvSpPr>
+          <p:nvPr>
+            <p:ph type="sldImg"/>
+          </p:nvPr>
+        </p:nvSpPr>
+        <p:spPr/>
+      </p:sp>
+      <p:sp>
+        <p:nvSpPr>
+          <p:cNvPr id="3" name="Notes Placeholder 2"/>
+          <p:cNvSpPr>
+            <a:spLocks noGrp="1"/>
+          </p:cNvSpPr>
+          <p:nvPr>
+            <p:ph type="body" idx="1"/>
+          </p:nvPr>
+        </p:nvSpPr>
+        <p:spPr/>
+        <p:txBody>
+          <a:bodyPr/>
+          <a:lstStyle/>
+          <a:p>
+            <a:r>
+              <a:rPr lang="en-US" dirty="0"/>
+              <a:t/>
+            </a:r>
+            <a:endParaRPr lang="en-US" dirty="0"/>
+          </a:p>
+        </p:txBody>
+      </p:sp>
+      <p:sp>
+        <p:nvSpPr>
+          <p:cNvPr id="4" name="Slide Number Placeholder 3"/>
+          <p:cNvSpPr>
+            <a:spLocks noGrp="1"/>
+          </p:cNvSpPr>
+          <p:nvPr>
+            <p:ph type="sldNum" sz="quarter" idx="10"/>
+          </p:nvPr>
+        </p:nvSpPr>
+        <p:spPr/>
+        <p:txBody>
+          <a:bodyPr/>
+          <a:lstStyle/>
+          <a:p>
+            <a:fld id="{F7021451-1387-4CA6-816F-3879F97B5CBC}" type="slidenum">
+              <a:rPr lang="en-US"/>
+              <a:t>28</a:t>
             </a:fld>
             <a:endParaRPr lang="en-US"/>
           </a:p>
@@ -16988,7 +17078,7 @@
         </p:nvSpPr>
         <p:spPr>
           <a:xfrm>
-            <a:off x="822960" y="1600200"/>
+            <a:off x="822960" y="1554480"/>
             <a:ext cx="3017520" cy="731520"/>
           </a:xfrm>
           <a:prstGeom prst="rect">
@@ -17005,14 +17095,14 @@
               <a:buNone/>
             </a:pPr>
             <a:r>
-              <a:rPr lang="en-US" sz="3200" b="1" dirty="0">
+              <a:rPr lang="en-US" sz="3000" b="1" dirty="0">
                 <a:solidFill>
-                  <a:schemeClr val="accent3"/>
+                  <a:schemeClr val="accent1"/>
                 </a:solidFill>
               </a:rPr>
-              <a:t>[PENDING]</a:t>
+              <a:t>97.6% ± 0.5</a:t>
             </a:r>
-            <a:endParaRPr lang="en-US" sz="3200" dirty="0"/>
+            <a:endParaRPr lang="en-US" sz="3000" dirty="0"/>
           </a:p>
         </p:txBody>
       </p:sp>
@@ -17024,8 +17114,8 @@
         </p:nvSpPr>
         <p:spPr>
           <a:xfrm>
-            <a:off x="822960" y="2377440"/>
-            <a:ext cx="3017520" cy="457200"/>
+            <a:off x="822960" y="2286000"/>
+            <a:ext cx="3017520" cy="640080"/>
           </a:xfrm>
           <a:prstGeom prst="rect">
             <a:avLst/>
@@ -17041,14 +17131,14 @@
               <a:buNone/>
             </a:pPr>
             <a:r>
-              <a:rPr lang="en-US" sz="1500" dirty="0">
+              <a:rPr lang="en-US" sz="1400" dirty="0">
                 <a:solidFill>
                   <a:schemeClr val="tx2"/>
                 </a:solidFill>
               </a:rPr>
-              <a:t>Accuracy, balanced test set (± std)</a:t>
+              <a:t>Accuracy on the class-balanced test set</a:t>
             </a:r>
-            <a:endParaRPr lang="en-US" sz="1500" dirty="0"/>
+            <a:endParaRPr lang="en-US" sz="1400" dirty="0"/>
           </a:p>
         </p:txBody>
       </p:sp>
@@ -17087,7 +17177,7 @@
         </p:nvSpPr>
         <p:spPr>
           <a:xfrm>
-            <a:off x="4572000" y="1600200"/>
+            <a:off x="4572000" y="1554480"/>
             <a:ext cx="3017520" cy="731520"/>
           </a:xfrm>
           <a:prstGeom prst="rect">
@@ -17104,14 +17194,14 @@
               <a:buNone/>
             </a:pPr>
             <a:r>
-              <a:rPr lang="en-US" sz="3200" b="1" dirty="0">
+              <a:rPr lang="en-US" sz="3000" b="1" dirty="0">
                 <a:solidFill>
-                  <a:schemeClr val="accent3"/>
+                  <a:schemeClr val="accent1"/>
                 </a:solidFill>
               </a:rPr>
-              <a:t>[PENDING]</a:t>
+              <a:t>98.7%</a:t>
             </a:r>
-            <a:endParaRPr lang="en-US" sz="3200" dirty="0"/>
+            <a:endParaRPr lang="en-US" sz="3000" dirty="0"/>
           </a:p>
         </p:txBody>
       </p:sp>
@@ -17123,8 +17213,8 @@
         </p:nvSpPr>
         <p:spPr>
           <a:xfrm>
-            <a:off x="4572000" y="2377440"/>
-            <a:ext cx="3017520" cy="457200"/>
+            <a:off x="4572000" y="2286000"/>
+            <a:ext cx="3017520" cy="640080"/>
           </a:xfrm>
           <a:prstGeom prst="rect">
             <a:avLst/>
@@ -17140,14 +17230,14 @@
               <a:buNone/>
             </a:pPr>
             <a:r>
-              <a:rPr lang="en-US" sz="1500" dirty="0">
+              <a:rPr lang="en-US" sz="1400" dirty="0">
                 <a:solidFill>
                   <a:schemeClr val="tx2"/>
                 </a:solidFill>
               </a:rPr>
-              <a:t>Macro F1, balanced test set</a:t>
+              <a:t>Test accuracy · macro F1 97.1% · ROC-AUC 0.9997</a:t>
             </a:r>
-            <a:endParaRPr lang="en-US" sz="1500" dirty="0"/>
+            <a:endParaRPr lang="en-US" sz="1400" dirty="0"/>
           </a:p>
         </p:txBody>
       </p:sp>
@@ -17186,7 +17276,7 @@
         </p:nvSpPr>
         <p:spPr>
           <a:xfrm>
-            <a:off x="8321040" y="1600200"/>
+            <a:off x="8321040" y="1554480"/>
             <a:ext cx="3017520" cy="731520"/>
           </a:xfrm>
           <a:prstGeom prst="rect">
@@ -17203,14 +17293,14 @@
               <a:buNone/>
             </a:pPr>
             <a:r>
-              <a:rPr lang="en-US" sz="3200" b="1" dirty="0">
+              <a:rPr lang="en-US" sz="3000" b="1" dirty="0">
                 <a:solidFill>
-                  <a:schemeClr val="accent3"/>
+                  <a:schemeClr val="accent1"/>
                 </a:solidFill>
               </a:rPr>
-              <a:t>[PENDING]</a:t>
+              <a:t>94.2 → 98.7%</a:t>
             </a:r>
-            <a:endParaRPr lang="en-US" sz="3200" dirty="0"/>
+            <a:endParaRPr lang="en-US" sz="3000" dirty="0"/>
           </a:p>
         </p:txBody>
       </p:sp>
@@ -17222,8 +17312,8 @@
         </p:nvSpPr>
         <p:spPr>
           <a:xfrm>
-            <a:off x="8321040" y="2377440"/>
-            <a:ext cx="3017520" cy="457200"/>
+            <a:off x="8321040" y="2286000"/>
+            <a:ext cx="3017520" cy="640080"/>
           </a:xfrm>
           <a:prstGeom prst="rect">
             <a:avLst/>
@@ -17239,14 +17329,14 @@
               <a:buNone/>
             </a:pPr>
             <a:r>
-              <a:rPr lang="en-US" sz="1500" dirty="0">
+              <a:rPr lang="en-US" sz="1400" dirty="0">
                 <a:solidFill>
                   <a:schemeClr val="tx2"/>
                 </a:solidFill>
               </a:rPr>
-              <a:t>Balanced accuracy / ROC-AUC</a:t>
+              <a:t>Ablation: accuracy without byte-scrambling augmentation</a:t>
             </a:r>
-            <a:endParaRPr lang="en-US" sz="1500" dirty="0"/>
+            <a:endParaRPr lang="en-US" sz="1400" dirty="0"/>
           </a:p>
         </p:txBody>
       </p:sp>
@@ -17285,7 +17375,7 @@
         </p:nvSpPr>
         <p:spPr>
           <a:xfrm>
-            <a:off x="822960" y="3429000"/>
+            <a:off x="822960" y="3383280"/>
             <a:ext cx="3017520" cy="731520"/>
           </a:xfrm>
           <a:prstGeom prst="rect">
@@ -17302,14 +17392,14 @@
               <a:buNone/>
             </a:pPr>
             <a:r>
-              <a:rPr lang="en-US" sz="3200" b="1" dirty="0">
+              <a:rPr lang="en-US" sz="3000" b="1" dirty="0">
                 <a:solidFill>
                   <a:schemeClr val="accent3"/>
                 </a:solidFill>
               </a:rPr>
               <a:t>[PENDING]</a:t>
             </a:r>
-            <a:endParaRPr lang="en-US" sz="3200" dirty="0"/>
+            <a:endParaRPr lang="en-US" sz="3000" dirty="0"/>
           </a:p>
         </p:txBody>
       </p:sp>
@@ -17321,8 +17411,8 @@
         </p:nvSpPr>
         <p:spPr>
           <a:xfrm>
-            <a:off x="822960" y="4206240"/>
-            <a:ext cx="3017520" cy="457200"/>
+            <a:off x="822960" y="4114800"/>
+            <a:ext cx="3017520" cy="640080"/>
           </a:xfrm>
           <a:prstGeom prst="rect">
             <a:avLst/>
@@ -17338,14 +17428,14 @@
               <a:buNone/>
             </a:pPr>
             <a:r>
-              <a:rPr lang="en-US" sz="1500" dirty="0">
+              <a:rPr lang="en-US" sz="1400" dirty="0">
                 <a:solidFill>
                   <a:schemeClr val="tx2"/>
                 </a:solidFill>
               </a:rPr>
               <a:t>Clean files called malware</a:t>
             </a:r>
-            <a:endParaRPr lang="en-US" sz="1500" dirty="0"/>
+            <a:endParaRPr lang="en-US" sz="1400" dirty="0"/>
           </a:p>
         </p:txBody>
       </p:sp>
@@ -17384,7 +17474,7 @@
         </p:nvSpPr>
         <p:spPr>
           <a:xfrm>
-            <a:off x="4572000" y="3429000"/>
+            <a:off x="4572000" y="3383280"/>
             <a:ext cx="3017520" cy="731520"/>
           </a:xfrm>
           <a:prstGeom prst="rect">
@@ -17401,14 +17491,14 @@
               <a:buNone/>
             </a:pPr>
             <a:r>
-              <a:rPr lang="en-US" sz="3200" b="1" dirty="0">
+              <a:rPr lang="en-US" sz="3000" b="1" dirty="0">
                 <a:solidFill>
-                  <a:schemeClr val="accent3"/>
+                  <a:schemeClr val="accent1"/>
                 </a:solidFill>
               </a:rPr>
-              <a:t>[PENDING]</a:t>
+              <a:t>0.80</a:t>
             </a:r>
-            <a:endParaRPr lang="en-US" sz="3200" dirty="0"/>
+            <a:endParaRPr lang="en-US" sz="3000" dirty="0"/>
           </a:p>
         </p:txBody>
       </p:sp>
@@ -17420,8 +17510,8 @@
         </p:nvSpPr>
         <p:spPr>
           <a:xfrm>
-            <a:off x="4572000" y="4206240"/>
-            <a:ext cx="3017520" cy="457200"/>
+            <a:off x="4572000" y="4114800"/>
+            <a:ext cx="3017520" cy="640080"/>
           </a:xfrm>
           <a:prstGeom prst="rect">
             <a:avLst/>
@@ -17437,14 +17527,14 @@
               <a:buNone/>
             </a:pPr>
             <a:r>
-              <a:rPr lang="en-US" sz="1500" dirty="0">
+              <a:rPr lang="en-US" sz="1400" dirty="0">
                 <a:solidFill>
                   <a:schemeClr val="tx2"/>
                 </a:solidFill>
               </a:rPr>
-              <a:t>Unseen-family AUROC</a:t>
+              <a:t>Unseen-family AUROC — confidence alone misses new variants</a:t>
             </a:r>
-            <a:endParaRPr lang="en-US" sz="1500" dirty="0"/>
+            <a:endParaRPr lang="en-US" sz="1400" dirty="0"/>
           </a:p>
         </p:txBody>
       </p:sp>
@@ -17483,7 +17573,7 @@
         </p:nvSpPr>
         <p:spPr>
           <a:xfrm>
-            <a:off x="8321040" y="3429000"/>
+            <a:off x="8321040" y="3383280"/>
             <a:ext cx="3017520" cy="731520"/>
           </a:xfrm>
           <a:prstGeom prst="rect">
@@ -17500,14 +17590,14 @@
               <a:buNone/>
             </a:pPr>
             <a:r>
-              <a:rPr lang="en-US" sz="3200" b="1" dirty="0">
+              <a:rPr lang="en-US" sz="3000" b="1" dirty="0">
                 <a:solidFill>
                   <a:schemeClr val="accent3"/>
                 </a:solidFill>
               </a:rPr>
               <a:t>[PENDING]</a:t>
             </a:r>
-            <a:endParaRPr lang="en-US" sz="3200" dirty="0"/>
+            <a:endParaRPr lang="en-US" sz="3000" dirty="0"/>
           </a:p>
         </p:txBody>
       </p:sp>
@@ -17519,8 +17609,8 @@
         </p:nvSpPr>
         <p:spPr>
           <a:xfrm>
-            <a:off x="8321040" y="4206240"/>
-            <a:ext cx="3017520" cy="457200"/>
+            <a:off x="8321040" y="4114800"/>
+            <a:ext cx="3017520" cy="640080"/>
           </a:xfrm>
           <a:prstGeom prst="rect">
             <a:avLst/>
@@ -17536,14 +17626,14 @@
               <a:buNone/>
             </a:pPr>
             <a:r>
-              <a:rPr lang="en-US" sz="1500" dirty="0">
+              <a:rPr lang="en-US" sz="1400" dirty="0">
                 <a:solidFill>
                   <a:schemeClr val="tx2"/>
                 </a:solidFill>
               </a:rPr>
               <a:t>IoT-23 detection rate / FPR</a:t>
             </a:r>
-            <a:endParaRPr lang="en-US" sz="1500" dirty="0"/>
+            <a:endParaRPr lang="en-US" sz="1400" dirty="0"/>
           </a:p>
         </p:txBody>
       </p:sp>
@@ -17663,8 +17753,8 @@
         </p:nvSpPr>
         <p:spPr>
           <a:xfrm>
-            <a:off x="640080" y="2743200"/>
-            <a:ext cx="10515600" cy="1005840"/>
+            <a:off x="548640" y="320040"/>
+            <a:ext cx="11064240" cy="777240"/>
           </a:xfrm>
           <a:prstGeom prst="rect">
             <a:avLst/>
@@ -17673,21 +17763,235 @@
           <a:ln/>
         </p:spPr>
         <p:txBody>
-          <a:bodyPr wrap="square" rtlCol="0"/>
+          <a:bodyPr wrap="square" rtlCol="0" anchor="ctr"/>
           <a:lstStyle/>
           <a:p>
-            <a:pPr algn="l" indent="0" marL="0">
+            <a:pPr indent="0" marL="0">
               <a:buNone/>
             </a:pPr>
             <a:r>
-              <a:rPr lang="en-US" sz="4000" b="1" dirty="0">
+              <a:rPr lang="en-US" sz="3200" b="1" dirty="0">
                 <a:solidFill>
-                  <a:schemeClr val="bg1"/>
+                  <a:schemeClr val="tx1"/>
                 </a:solidFill>
               </a:rPr>
-              <a:t>Next steps</a:t>
+              <a:t>Static model: training and errors</a:t>
             </a:r>
-            <a:endParaRPr lang="en-US" sz="4000" dirty="0"/>
+            <a:endParaRPr lang="en-US" sz="3200" dirty="0"/>
+          </a:p>
+        </p:txBody>
+      </p:sp>
+      <p:pic>
+        <p:nvPicPr>
+          <p:cNvPr id="3" name="Image 0" descr="/tmp/claude-0/-home-claude-maltwin/b0d3e466-e30c-58b7-82f4-5b5331a1e75f/scratchpad/deck/res_training_curves.png">    </p:cNvPr>
+          <p:cNvPicPr>
+            <a:picLocks noChangeAspect="1"/>
+          </p:cNvPicPr>
+          <p:nvPr/>
+        </p:nvPicPr>
+        <p:blipFill>
+          <a:blip r:embed="rId1"/>
+          <a:stretch>
+            <a:fillRect/>
+          </a:stretch>
+        </p:blipFill>
+        <p:spPr>
+          <a:xfrm>
+            <a:off x="548640" y="1325880"/>
+            <a:ext cx="6035040" cy="2217919"/>
+          </a:xfrm>
+          <a:prstGeom prst="rect">
+            <a:avLst/>
+          </a:prstGeom>
+        </p:spPr>
+      </p:pic>
+      <p:sp>
+        <p:nvSpPr>
+          <p:cNvPr id="4" name="Text 1"/>
+          <p:cNvSpPr txBox="1"/>
+          <p:nvPr/>
+        </p:nvSpPr>
+        <p:spPr>
+          <a:xfrm>
+            <a:off x="548640" y="3589519"/>
+            <a:ext cx="6035040" cy="320040"/>
+          </a:xfrm>
+          <a:prstGeom prst="rect">
+            <a:avLst/>
+          </a:prstGeom>
+          <a:noFill/>
+          <a:ln/>
+        </p:spPr>
+        <p:txBody>
+          <a:bodyPr wrap="square" lIns="0" tIns="0" rIns="0" bIns="0" rtlCol="0" anchor="t"/>
+          <a:lstStyle/>
+          <a:p>
+            <a:pPr algn="ctr" indent="0" marL="0">
+              <a:buNone/>
+            </a:pPr>
+            <a:r>
+              <a:rPr lang="en-US" sz="1200" dirty="0">
+                <a:solidFill>
+                  <a:schemeClr val="accent5"/>
+                </a:solidFill>
+              </a:rPr>
+              <a:t>Training curves — 30 epochs, no augmentation, best at epoch 29</a:t>
+            </a:r>
+            <a:endParaRPr lang="en-US" sz="1200" dirty="0"/>
+          </a:p>
+        </p:txBody>
+      </p:sp>
+      <p:sp>
+        <p:nvSpPr>
+          <p:cNvPr id="5" name="Text 2"/>
+          <p:cNvSpPr txBox="1"/>
+          <p:nvPr/>
+        </p:nvSpPr>
+        <p:spPr>
+          <a:xfrm>
+            <a:off x="548640" y="4343400"/>
+            <a:ext cx="6035040" cy="1645920"/>
+          </a:xfrm>
+          <a:prstGeom prst="rect">
+            <a:avLst/>
+          </a:prstGeom>
+          <a:noFill/>
+          <a:ln/>
+        </p:spPr>
+        <p:txBody>
+          <a:bodyPr wrap="square" lIns="0" tIns="0" rIns="0" bIns="0" rtlCol="0" anchor="t"/>
+          <a:lstStyle/>
+          <a:p>
+            <a:pPr marL="228600" indent="-228600">
+              <a:spcAft>
+                <a:spcPts val="600"/>
+              </a:spcAft>
+              <a:buSzPct val="100000"/>
+              <a:buChar char="•"/>
+            </a:pPr>
+            <a:r>
+              <a:rPr lang="en-US" sz="1500" dirty="0">
+                <a:solidFill>
+                  <a:schemeClr val="tx1"/>
+                </a:solidFill>
+              </a:rPr>
+              <a:t>Trained on a balanced dataset: every family drawn equally often</a:t>
+            </a:r>
+            <a:endParaRPr lang="en-US" sz="1500" dirty="0"/>
+          </a:p>
+          <a:p>
+            <a:pPr marL="228600" indent="-228600">
+              <a:spcAft>
+                <a:spcPts val="600"/>
+              </a:spcAft>
+              <a:buSzPct val="100000"/>
+              <a:buChar char="•"/>
+            </a:pPr>
+            <a:r>
+              <a:rPr lang="en-US" sz="1500" dirty="0">
+                <a:solidFill>
+                  <a:schemeClr val="tx1"/>
+                </a:solidFill>
+              </a:rPr>
+              <a:t>Balanced test set: 97.6% ± 0.5 (10 draws, 12 images × 26 classes)</a:t>
+            </a:r>
+            <a:endParaRPr lang="en-US" sz="1500" dirty="0"/>
+          </a:p>
+          <a:p>
+            <a:pPr marL="228600" indent="-228600">
+              <a:spcAft>
+                <a:spcPts val="600"/>
+              </a:spcAft>
+              <a:buSzPct val="100000"/>
+              <a:buChar char="•"/>
+            </a:pPr>
+            <a:r>
+              <a:rPr lang="en-US" sz="1500" dirty="0">
+                <a:solidFill>
+                  <a:schemeClr val="tx1"/>
+                </a:solidFill>
+              </a:rPr>
+              <a:t>No test-set malware was classified as Benign (precision 1.00)</a:t>
+            </a:r>
+            <a:endParaRPr lang="en-US" sz="1500" dirty="0"/>
+          </a:p>
+          <a:p>
+            <a:pPr marL="228600" indent="-228600">
+              <a:spcAft>
+                <a:spcPts val="600"/>
+              </a:spcAft>
+              <a:buSzPct val="100000"/>
+              <a:buChar char="•"/>
+            </a:pPr>
+            <a:r>
+              <a:rPr lang="en-US" sz="1500" dirty="0">
+                <a:solidFill>
+                  <a:schemeClr val="tx1"/>
+                </a:solidFill>
+              </a:rPr>
+              <a:t>Main confusion: Swizzor.gen!E vs Swizzor.gen!I — near-identical variants</a:t>
+            </a:r>
+            <a:endParaRPr lang="en-US" sz="1500" dirty="0"/>
+          </a:p>
+        </p:txBody>
+      </p:sp>
+      <p:pic>
+        <p:nvPicPr>
+          <p:cNvPr id="6" name="Image 1" descr="/tmp/claude-0/-home-claude-maltwin/b0d3e466-e30c-58b7-82f4-5b5331a1e75f/scratchpad/deck/res_confusion_matrix.png">    </p:cNvPr>
+          <p:cNvPicPr>
+            <a:picLocks noChangeAspect="1"/>
+          </p:cNvPicPr>
+          <p:nvPr/>
+        </p:nvPicPr>
+        <p:blipFill>
+          <a:blip r:embed="rId2"/>
+          <a:stretch>
+            <a:fillRect/>
+          </a:stretch>
+        </p:blipFill>
+        <p:spPr>
+          <a:xfrm>
+            <a:off x="6858000" y="1280160"/>
+            <a:ext cx="4754880" cy="4407698"/>
+          </a:xfrm>
+          <a:prstGeom prst="rect">
+            <a:avLst/>
+          </a:prstGeom>
+        </p:spPr>
+      </p:pic>
+      <p:sp>
+        <p:nvSpPr>
+          <p:cNvPr id="7" name="Text 3"/>
+          <p:cNvSpPr txBox="1"/>
+          <p:nvPr/>
+        </p:nvSpPr>
+        <p:spPr>
+          <a:xfrm>
+            <a:off x="6858000" y="5733578"/>
+            <a:ext cx="4754880" cy="320040"/>
+          </a:xfrm>
+          <a:prstGeom prst="rect">
+            <a:avLst/>
+          </a:prstGeom>
+          <a:noFill/>
+          <a:ln/>
+        </p:spPr>
+        <p:txBody>
+          <a:bodyPr wrap="square" lIns="0" tIns="0" rIns="0" bIns="0" rtlCol="0" anchor="t"/>
+          <a:lstStyle/>
+          <a:p>
+            <a:pPr algn="ctr" indent="0" marL="0">
+              <a:buNone/>
+            </a:pPr>
+            <a:r>
+              <a:rPr lang="en-US" sz="1200" dirty="0">
+                <a:solidFill>
+                  <a:schemeClr val="accent5"/>
+                </a:solidFill>
+              </a:rPr>
+              <a:t>Confusion matrix, 26 classes</a:t>
+            </a:r>
+            <a:endParaRPr lang="en-US" sz="1200" dirty="0"/>
           </a:p>
         </p:txBody>
       </p:sp>
@@ -17771,6 +18075,114 @@
         </p:nvSpPr>
         <p:spPr>
           <a:xfrm>
+            <a:off x="640080" y="2743200"/>
+            <a:ext cx="10515600" cy="1005840"/>
+          </a:xfrm>
+          <a:prstGeom prst="rect">
+            <a:avLst/>
+          </a:prstGeom>
+          <a:noFill/>
+          <a:ln/>
+        </p:spPr>
+        <p:txBody>
+          <a:bodyPr wrap="square" rtlCol="0"/>
+          <a:lstStyle/>
+          <a:p>
+            <a:pPr algn="l" indent="0" marL="0">
+              <a:buNone/>
+            </a:pPr>
+            <a:r>
+              <a:rPr lang="en-US" sz="4000" b="1" dirty="0">
+                <a:solidFill>
+                  <a:schemeClr val="bg1"/>
+                </a:solidFill>
+              </a:rPr>
+              <a:t>Next steps</a:t>
+            </a:r>
+            <a:endParaRPr lang="en-US" sz="4000" dirty="0"/>
+          </a:p>
+        </p:txBody>
+      </p:sp>
+      <p:sp>
+        <p:nvSpPr>
+          <p:cNvPr id="25" name="Slide Number Placeholder 0"/>
+          <p:cNvSpPr>
+            <a:spLocks noGrp="1"/>
+          </p:cNvSpPr>
+          <p:nvPr>
+            <p:ph type="sldNum" sz="quarter" idx="4294967295"/>
+          </p:nvPr>
+        </p:nvSpPr>
+        <p:spPr>
+          <a:xfrm>
+            <a:off x="11338560" y="6355080"/>
+            <a:ext cx="548640" cy="320040"/>
+          </a:xfrm>
+          <a:prstGeom prst="rect">
+            <a:avLst/>
+          </a:prstGeom>
+          <a:extLst>
+            <a:ext uri="{C572A759-6A51-4108-AA02-DFA0A04FC94B}">
+              <ma14:wrappingTextBoxFlag xmlns:ma14="http://schemas.microsoft.com/office/mac/drawingml/2011/main" val="0"/>
+            </a:ext>
+          </a:extLst>
+        </p:spPr>
+        <p:txBody>
+          <a:bodyPr/>
+          <a:lstStyle>
+            <a:lvl1pPr>
+              <a:defRPr sz="1100">
+                <a:solidFill>
+                  <a:schemeClr val="accent5"/>
+                </a:solidFill>
+              </a:defRPr>
+            </a:lvl1pPr>
+          </a:lstStyle>
+          <a:p>
+            <a:pPr algn="l"/>
+            <a:fld id="{F7021451-1387-4CA6-816F-3879F97B5CBC}" type="slidenum">
+              <a:rPr b="0" lang="en-US"/>
+              <a:t>26</a:t>
+            </a:fld>
+            <a:endParaRPr lang="en-US"/>
+          </a:p>
+        </p:txBody>
+      </p:sp>
+    </p:spTree>
+  </p:cSld>
+  <p:clrMapOvr>
+    <a:masterClrMapping/>
+  </p:clrMapOvr>
+</p:sld>
+</file>
+
+<file path=ppt/slides/slide27.xml><?xml version="1.0" encoding="utf-8"?>
+<p:sld xmlns:a="http://schemas.openxmlformats.org/drawingml/2006/main" xmlns:r="http://schemas.openxmlformats.org/officeDocument/2006/relationships" xmlns:p="http://schemas.openxmlformats.org/presentationml/2006/main">
+  <p:cSld name="Slide 27">
+    <p:spTree>
+      <p:nvGrpSpPr>
+        <p:cNvPr id="1" name=""/>
+        <p:cNvGrpSpPr/>
+        <p:nvPr/>
+      </p:nvGrpSpPr>
+      <p:grpSpPr>
+        <a:xfrm>
+          <a:off x="0" y="0"/>
+          <a:ext cx="0" cy="0"/>
+          <a:chOff x="0" y="0"/>
+          <a:chExt cx="0" cy="0"/>
+        </a:xfrm>
+      </p:grpSpPr>
+      <p:sp>
+        <p:nvSpPr>
+          <p:cNvPr id="2" name="Text 0"/>
+          <p:cNvSpPr/>
+          <p:nvPr>
+            <p:ph idx="100" type="title" hasCustomPrompt="1"/>
+          </p:nvPr>
+        </p:nvSpPr>
+        <p:spPr>
+          <a:xfrm>
             <a:off x="548640" y="320040"/>
             <a:ext cx="11064240" cy="777240"/>
           </a:xfrm>
@@ -18436,7 +18848,7 @@
             <a:pPr algn="l"/>
             <a:fld id="{F7021451-1387-4CA6-816F-3879F97B5CBC}" type="slidenum">
               <a:rPr b="0" lang="en-US"/>
-              <a:t>26</a:t>
+              <a:t>27</a:t>
             </a:fld>
             <a:endParaRPr lang="en-US"/>
           </a:p>
@@ -18450,9 +18862,9 @@
 </p:sld>
 </file>
 
-<file path=ppt/slides/slide27.xml><?xml version="1.0" encoding="utf-8"?>
+<file path=ppt/slides/slide28.xml><?xml version="1.0" encoding="utf-8"?>
 <p:sld xmlns:a="http://schemas.openxmlformats.org/drawingml/2006/main" xmlns:r="http://schemas.openxmlformats.org/officeDocument/2006/relationships" xmlns:p="http://schemas.openxmlformats.org/presentationml/2006/main">
-  <p:cSld name="Slide 27">
+  <p:cSld name="Slide 28">
     <p:spTree>
       <p:nvGrpSpPr>
         <p:cNvPr id="1" name=""/>

</xml_diff>

<commit_message>
Deck: clean-application result tile
Co-Authored-By: Claude Opus 5.5 <noreply@anthropic.com>
Claude-Session: https://claude.ai/code/session_015h4SwWvXQGuvs9F8VqDPvi
</commit_message>
<xml_diff>
--- a/docs/MalTwin_60pct_Evaluation.pptx
+++ b/docs/MalTwin_60pct_Evaluation.pptx
@@ -134,17 +134,17 @@
   <p:extLst>
     <p:ext uri="{521415D9-36F7-43E2-AB2F-B90AF26B5E84}">
       <p14:sectionLst xmlns:p14="http://schemas.microsoft.com/office/powerpoint/2010/main">
-        <p14:section name="Title" id="{3df0f332-a6d1-fda2-5a0e-6c5a4e83db95}">
+        <p14:section name="Title" id="{38309eb7-24bb-bbf1-84ad-509020b757fb}">
           <p14:sldIdLst>
             <p14:sldId id="256"/>
           </p14:sldIdLst>
         </p14:section>
-        <p14:section name="Introduction" id="{5613ac2f-2377-6b94-967b-39457ec50b62}">
+        <p14:section name="Introduction" id="{c33da052-6fdc-7b68-2b28-243a2c057eb8}">
           <p14:sldIdLst>
             <p14:sldId id="257"/>
           </p14:sldIdLst>
         </p14:section>
-        <p14:section name="Changes since 30%" id="{de51c16e-08d6-59f3-ee97-5f99d1423356}">
+        <p14:section name="Changes since 30%" id="{877cf09c-f4a6-5cee-cd53-1347b90fbaed}">
           <p14:sldIdLst>
             <p14:sldId id="258"/>
             <p14:sldId id="259"/>
@@ -153,7 +153,7 @@
             <p14:sldId id="262"/>
           </p14:sldIdLst>
         </p14:section>
-        <p14:section name="Implemented modules" id="{abb18a90-cf05-ead3-7eef-6eb8ec54bfdb}">
+        <p14:section name="Implemented modules" id="{73ddfa73-1bc4-038d-dc0e-2afb06476d9c}">
           <p14:sldIdLst>
             <p14:sldId id="263"/>
             <p14:sldId id="264"/>
@@ -163,14 +163,14 @@
             <p14:sldId id="268"/>
           </p14:sldIdLst>
         </p14:section>
-        <p14:section name="Testing" id="{25c65a96-cb0f-b3a6-1fa8-d4503b37abbc}">
+        <p14:section name="Testing" id="{fb7bbad6-a8a2-ecce-fc7a-ac3f3ce64170}">
           <p14:sldIdLst>
             <p14:sldId id="269"/>
             <p14:sldId id="270"/>
             <p14:sldId id="271"/>
           </p14:sldIdLst>
         </p14:section>
-        <p14:section name="Automated testing" id="{7f9c89a0-dd14-21e6-bf4a-c3803721237e}">
+        <p14:section name="Automated testing" id="{bf5b530b-53cd-eb2a-d7ce-64f9becdf667}">
           <p14:sldIdLst>
             <p14:sldId id="272"/>
             <p14:sldId id="273"/>
@@ -179,7 +179,7 @@
             <p14:sldId id="276"/>
           </p14:sldIdLst>
         </p14:section>
-        <p14:section name="AI / ML techniques" id="{ff75fd98-02e7-42c8-5876-146d77f3ffcd}">
+        <p14:section name="AI / ML techniques" id="{de3d08bf-5113-3d53-1ed8-28819dff6f71}">
           <p14:sldIdLst>
             <p14:sldId id="277"/>
             <p14:sldId id="278"/>
@@ -187,13 +187,13 @@
             <p14:sldId id="280"/>
           </p14:sldIdLst>
         </p14:section>
-        <p14:section name="Next steps" id="{93c8d397-e7ce-6050-3b22-f24fd3e79970}">
+        <p14:section name="Next steps" id="{80f1ef76-cca9-e6b9-ea69-d38a93fb2aa0}">
           <p14:sldIdLst>
             <p14:sldId id="281"/>
             <p14:sldId id="282"/>
           </p14:sldIdLst>
         </p14:section>
-        <p14:section name="Close" id="{622411cb-de7a-d5a8-180f-ae86ccb9273b}">
+        <p14:section name="Close" id="{8447c9a9-524c-ef10-a000-8699edf809a8}">
           <p14:sldIdLst>
             <p14:sldId id="283"/>
           </p14:sldIdLst>
@@ -17394,10 +17394,10 @@
             <a:r>
               <a:rPr lang="en-US" sz="3000" b="1" dirty="0">
                 <a:solidFill>
-                  <a:schemeClr val="accent3"/>
+                  <a:schemeClr val="accent1"/>
                 </a:solidFill>
               </a:rPr>
-              <a:t>[PENDING]</a:t>
+              <a:t>10.2%</a:t>
             </a:r>
             <a:endParaRPr lang="en-US" sz="3000" dirty="0"/>
           </a:p>
@@ -17433,7 +17433,7 @@
                   <a:schemeClr val="tx2"/>
                 </a:solidFill>
               </a:rPr>
-              <a:t>Clean files called malware</a:t>
+              <a:t>Clean apps flagged as malware (6.4% confident) — mostly Visual Basic</a:t>
             </a:r>
             <a:endParaRPr lang="en-US" sz="1400" dirty="0"/>
           </a:p>

</xml_diff>

<commit_message>
Document 4 and deck: IoT-23 results, laptop benchmark, dashboard screenshots, defects D14-D17
Co-Authored-By: Claude Opus 5.5 <noreply@anthropic.com>
Claude-Session: https://claude.ai/code/session_015h4SwWvXQGuvs9F8VqDPvi
</commit_message>
<xml_diff>
--- a/docs/MalTwin_60pct_Evaluation.pptx
+++ b/docs/MalTwin_60pct_Evaluation.pptx
@@ -33,9 +33,10 @@
     <p:sldId id="281" r:id="rId27"/>
     <p:sldId id="282" r:id="rId28"/>
     <p:sldId id="283" r:id="rId29"/>
+    <p:sldId id="284" r:id="rId30"/>
   </p:sldIdLst>
   <p:notesMasterIdLst>
-    <p:notesMasterId r:id="rId30"/>
+    <p:notesMasterId r:id="rId31"/>
   </p:notesMasterIdLst>
   <p:sldSz cx="12192000" cy="6858000"/>
   <p:notesSz cx="6858000" cy="12192000"/>
@@ -134,17 +135,17 @@
   <p:extLst>
     <p:ext uri="{521415D9-36F7-43E2-AB2F-B90AF26B5E84}">
       <p14:sectionLst xmlns:p14="http://schemas.microsoft.com/office/powerpoint/2010/main">
-        <p14:section name="Title" id="{38309eb7-24bb-bbf1-84ad-509020b757fb}">
+        <p14:section name="Title" id="{8553df1e-d3b6-35bb-4d96-dc23c70685b7}">
           <p14:sldIdLst>
             <p14:sldId id="256"/>
           </p14:sldIdLst>
         </p14:section>
-        <p14:section name="Introduction" id="{c33da052-6fdc-7b68-2b28-243a2c057eb8}">
+        <p14:section name="Introduction" id="{e6beafc7-318a-f643-e73f-bd3982b988a5}">
           <p14:sldIdLst>
             <p14:sldId id="257"/>
           </p14:sldIdLst>
         </p14:section>
-        <p14:section name="Changes since 30%" id="{877cf09c-f4a6-5cee-cd53-1347b90fbaed}">
+        <p14:section name="Changes since 30%" id="{723565f1-d06a-a557-f8db-12032674ee62}">
           <p14:sldIdLst>
             <p14:sldId id="258"/>
             <p14:sldId id="259"/>
@@ -153,7 +154,7 @@
             <p14:sldId id="262"/>
           </p14:sldIdLst>
         </p14:section>
-        <p14:section name="Implemented modules" id="{73ddfa73-1bc4-038d-dc0e-2afb06476d9c}">
+        <p14:section name="Implemented modules" id="{38e0f0bd-cc50-97da-790e-d35f5084a1a6}">
           <p14:sldIdLst>
             <p14:sldId id="263"/>
             <p14:sldId id="264"/>
@@ -163,14 +164,14 @@
             <p14:sldId id="268"/>
           </p14:sldIdLst>
         </p14:section>
-        <p14:section name="Testing" id="{fb7bbad6-a8a2-ecce-fc7a-ac3f3ce64170}">
+        <p14:section name="Testing" id="{4bac3380-1da5-4f3c-5665-e9fe5c4c227b}">
           <p14:sldIdLst>
             <p14:sldId id="269"/>
             <p14:sldId id="270"/>
             <p14:sldId id="271"/>
           </p14:sldIdLst>
         </p14:section>
-        <p14:section name="Automated testing" id="{bf5b530b-53cd-eb2a-d7ce-64f9becdf667}">
+        <p14:section name="Automated testing" id="{25e86322-3987-8b78-3d32-faf71336154d}">
           <p14:sldIdLst>
             <p14:sldId id="272"/>
             <p14:sldId id="273"/>
@@ -179,23 +180,24 @@
             <p14:sldId id="276"/>
           </p14:sldIdLst>
         </p14:section>
-        <p14:section name="AI / ML techniques" id="{de3d08bf-5113-3d53-1ed8-28819dff6f71}">
+        <p14:section name="AI / ML techniques" id="{ba898fd5-26f8-d34e-3b9a-7e1e1d795218}">
           <p14:sldIdLst>
             <p14:sldId id="277"/>
             <p14:sldId id="278"/>
             <p14:sldId id="279"/>
             <p14:sldId id="280"/>
+            <p14:sldId id="281"/>
           </p14:sldIdLst>
         </p14:section>
-        <p14:section name="Next steps" id="{80f1ef76-cca9-e6b9-ea69-d38a93fb2aa0}">
+        <p14:section name="Next steps" id="{c53165cc-b70c-3a6f-2b52-09fd15c00654}">
           <p14:sldIdLst>
-            <p14:sldId id="281"/>
             <p14:sldId id="282"/>
+            <p14:sldId id="283"/>
           </p14:sldIdLst>
         </p14:section>
-        <p14:section name="Close" id="{8447c9a9-524c-ef10-a000-8699edf809a8}">
+        <p14:section name="Close" id="{fa28578d-68d0-1ce4-ce5b-d41adb479799}">
           <p14:sldIdLst>
-            <p14:sldId id="283"/>
+            <p14:sldId id="284"/>
           </p14:sldIdLst>
         </p14:section>
       </p14:sectionLst>
@@ -2386,6 +2388,94 @@
             <a:fld id="{F7021451-1387-4CA6-816F-3879F97B5CBC}" type="slidenum">
               <a:rPr lang="en-US"/>
               <a:t>28</a:t>
+            </a:fld>
+            <a:endParaRPr lang="en-US"/>
+          </a:p>
+        </p:txBody>
+      </p:sp>
+    </p:spTree>
+    <p:extLst>
+      <p:ext uri="{BB962C8B-B14F-4D97-AF65-F5344CB8AC3E}">
+        <p14:creationId xmlns:p14="http://schemas.microsoft.com/office/powerpoint/2010/main" val="1024086991"/>
+      </p:ext>
+    </p:extLst>
+  </p:cSld>
+  <p:clrMapOvr>
+    <a:masterClrMapping/>
+  </p:clrMapOvr>
+</p:notes>
+</file>
+
+<file path=ppt/notesSlides/notesSlide29.xml><?xml version="1.0" encoding="utf-8"?>
+<p:notes xmlns:a="http://schemas.openxmlformats.org/drawingml/2006/main" xmlns:r="http://schemas.openxmlformats.org/officeDocument/2006/relationships" xmlns:p="http://schemas.openxmlformats.org/presentationml/2006/main">
+  <p:cSld>
+    <p:spTree>
+      <p:nvGrpSpPr>
+        <p:cNvPr id="1" name=""/>
+        <p:cNvGrpSpPr/>
+        <p:nvPr/>
+      </p:nvGrpSpPr>
+      <p:grpSpPr>
+        <a:xfrm>
+          <a:off x="0" y="0"/>
+          <a:ext cx="0" cy="0"/>
+          <a:chOff x="0" y="0"/>
+          <a:chExt cx="0" cy="0"/>
+        </a:xfrm>
+      </p:grpSpPr>
+      <p:sp>
+        <p:nvSpPr>
+          <p:cNvPr id="2" name="Slide Image Placeholder 1"/>
+          <p:cNvSpPr>
+            <a:spLocks noGrp="1" noRot="1" noChangeAspect="1"/>
+          </p:cNvSpPr>
+          <p:nvPr>
+            <p:ph type="sldImg"/>
+          </p:nvPr>
+        </p:nvSpPr>
+        <p:spPr/>
+      </p:sp>
+      <p:sp>
+        <p:nvSpPr>
+          <p:cNvPr id="3" name="Notes Placeholder 2"/>
+          <p:cNvSpPr>
+            <a:spLocks noGrp="1"/>
+          </p:cNvSpPr>
+          <p:nvPr>
+            <p:ph type="body" idx="1"/>
+          </p:nvPr>
+        </p:nvSpPr>
+        <p:spPr/>
+        <p:txBody>
+          <a:bodyPr/>
+          <a:lstStyle/>
+          <a:p>
+            <a:r>
+              <a:rPr lang="en-US" dirty="0"/>
+              <a:t/>
+            </a:r>
+            <a:endParaRPr lang="en-US" dirty="0"/>
+          </a:p>
+        </p:txBody>
+      </p:sp>
+      <p:sp>
+        <p:nvSpPr>
+          <p:cNvPr id="4" name="Slide Number Placeholder 3"/>
+          <p:cNvSpPr>
+            <a:spLocks noGrp="1"/>
+          </p:cNvSpPr>
+          <p:nvPr>
+            <p:ph type="sldNum" sz="quarter" idx="10"/>
+          </p:nvPr>
+        </p:nvSpPr>
+        <p:spPr/>
+        <p:txBody>
+          <a:bodyPr/>
+          <a:lstStyle/>
+          <a:p>
+            <a:fld id="{F7021451-1387-4CA6-816F-3879F97B5CBC}" type="slidenum">
+              <a:rPr lang="en-US"/>
+              <a:t>29</a:t>
             </a:fld>
             <a:endParaRPr lang="en-US"/>
           </a:p>
@@ -6521,7 +6611,7 @@
                   <a:schemeClr val="accent2"/>
                 </a:solidFill>
               </a:rPr>
-              <a:t>343</a:t>
+              <a:t>344</a:t>
             </a:r>
             <a:endParaRPr lang="en-US" sz="4800" dirty="0"/>
           </a:p>
@@ -6705,7 +6795,7 @@
                   <a:schemeClr val="accent2"/>
                 </a:solidFill>
               </a:rPr>
-              <a:t>34</a:t>
+              <a:t>35</a:t>
             </a:r>
             <a:endParaRPr lang="en-US" sz="4800" dirty="0"/>
           </a:p>
@@ -6777,7 +6867,7 @@
                   <a:schemeClr val="tx2"/>
                 </a:solidFill>
               </a:rPr>
-              <a:t>12 automated UI tests (AppTest) on every run + 22 browser tests (Playwright): uploads, buttons, errors</a:t>
+              <a:t>13 automated UI tests (AppTest) on every run + 22 browser tests (Playwright): uploads, buttons, errors</a:t>
             </a:r>
             <a:endParaRPr lang="en-US" sz="1400" dirty="0"/>
           </a:p>
@@ -7073,7 +7163,7 @@
                   <a:schemeClr val="accent2"/>
                 </a:solidFill>
               </a:rPr>
-              <a:t>9</a:t>
+              <a:t>20</a:t>
             </a:r>
             <a:endParaRPr lang="en-US" sz="4800" dirty="0"/>
           </a:p>
@@ -7145,7 +7235,7 @@
                   <a:schemeClr val="tx2"/>
                 </a:solidFill>
               </a:rPr>
-              <a:t>Modules working together: training pipeline, upload → detect → database → dashboard</a:t>
+              <a:t>9 module hand-offs + 11 automated tests on the real dataset and trained model</a:t>
             </a:r>
             <a:endParaRPr lang="en-US" sz="1400" dirty="0"/>
           </a:p>
@@ -7253,7 +7343,7 @@
                   <a:schemeClr val="tx1"/>
                 </a:solidFill>
               </a:rPr>
-              <a:t>Results: 0 open failures, 13 defects found and fixed</a:t>
+              <a:t>Results: 17 defects found, all fixed</a:t>
             </a:r>
             <a:endParaRPr lang="en-US" sz="3200" dirty="0"/>
           </a:p>
@@ -7606,7 +7696,7 @@
                             <a:srgbClr val="1B1F24"/>
                           </a:solidFill>
                         </a:rPr>
-                        <a:t>343</a:t>
+                        <a:t>344</a:t>
                       </a:r>
                       <a:endParaRPr lang="en-US" sz="1500" dirty="0"/>
                     </a:p>
@@ -7664,7 +7754,7 @@
                             <a:srgbClr val="1B1F24"/>
                           </a:solidFill>
                         </a:rPr>
-                        <a:t>343</a:t>
+                        <a:t>344</a:t>
                       </a:r>
                       <a:endParaRPr lang="en-US" sz="1500" dirty="0"/>
                     </a:p>
@@ -7840,7 +7930,7 @@
                             <a:srgbClr val="1B1F24"/>
                           </a:solidFill>
                         </a:rPr>
-                        <a:t>12</a:t>
+                        <a:t>13</a:t>
                       </a:r>
                       <a:endParaRPr lang="en-US" sz="1500" dirty="0"/>
                     </a:p>
@@ -7898,7 +7988,7 @@
                             <a:srgbClr val="1B1F24"/>
                           </a:solidFill>
                         </a:rPr>
-                        <a:t>12</a:t>
+                        <a:t>13</a:t>
                       </a:r>
                       <a:endParaRPr lang="en-US" sz="1500" dirty="0"/>
                     </a:p>
@@ -8484,7 +8574,7 @@
                             <a:srgbClr val="1B1F24"/>
                           </a:solidFill>
                         </a:rPr>
-                        <a:t>Integration</a:t>
+                        <a:t>Integration (manual)</a:t>
                       </a:r>
                       <a:endParaRPr lang="en-US" sz="1500" dirty="0"/>
                     </a:p>
@@ -8718,7 +8808,241 @@
                             <a:srgbClr val="1B1F24"/>
                           </a:solidFill>
                         </a:rPr>
-                        <a:t>Performance (SRS targets)</a:t>
+                        <a:t>Integration (real dataset)*</a:t>
+                      </a:r>
+                      <a:endParaRPr lang="en-US" sz="1500" dirty="0"/>
+                    </a:p>
+                  </a:txBody>
+                  <a:tcPr marL="73152" marR="73152" marT="73152" marB="73152">
+                    <a:lnL w="9525" cap="flat" cmpd="sng" algn="ctr">
+                      <a:solidFill>
+                        <a:srgbClr val="C9D1DB"/>
+                      </a:solidFill>
+                      <a:prstDash val="solid"/>
+                      <a:round/>
+                      <a:headEnd type="none" w="med" len="med"/>
+                      <a:tailEnd type="none" w="med" len="med"/>
+                    </a:lnL>
+                    <a:lnR w="9525" cap="flat" cmpd="sng" algn="ctr">
+                      <a:solidFill>
+                        <a:srgbClr val="C9D1DB"/>
+                      </a:solidFill>
+                      <a:prstDash val="solid"/>
+                      <a:round/>
+                      <a:headEnd type="none" w="med" len="med"/>
+                      <a:tailEnd type="none" w="med" len="med"/>
+                    </a:lnR>
+                    <a:lnT w="9525" cap="flat" cmpd="sng" algn="ctr">
+                      <a:solidFill>
+                        <a:srgbClr val="C9D1DB"/>
+                      </a:solidFill>
+                      <a:prstDash val="solid"/>
+                      <a:round/>
+                      <a:headEnd type="none" w="med" len="med"/>
+                      <a:tailEnd type="none" w="med" len="med"/>
+                    </a:lnT>
+                    <a:lnB w="9525" cap="flat" cmpd="sng" algn="ctr">
+                      <a:solidFill>
+                        <a:srgbClr val="C9D1DB"/>
+                      </a:solidFill>
+                      <a:prstDash val="solid"/>
+                      <a:round/>
+                      <a:headEnd type="none" w="med" len="med"/>
+                      <a:tailEnd type="none" w="med" len="med"/>
+                    </a:lnB>
+                  </a:tcPr>
+                </a:tc>
+                <a:tc>
+                  <a:txBody>
+                    <a:bodyPr/>
+                    <a:lstStyle/>
+                    <a:p>
+                      <a:pPr indent="0" marL="0">
+                        <a:buNone/>
+                      </a:pPr>
+                      <a:r>
+                        <a:rPr lang="en-US" sz="1500" dirty="0">
+                          <a:solidFill>
+                            <a:srgbClr val="1B1F24"/>
+                          </a:solidFill>
+                        </a:rPr>
+                        <a:t>11</a:t>
+                      </a:r>
+                      <a:endParaRPr lang="en-US" sz="1500" dirty="0"/>
+                    </a:p>
+                  </a:txBody>
+                  <a:tcPr marL="73152" marR="73152" marT="73152" marB="73152">
+                    <a:lnL w="9525" cap="flat" cmpd="sng" algn="ctr">
+                      <a:solidFill>
+                        <a:srgbClr val="C9D1DB"/>
+                      </a:solidFill>
+                      <a:prstDash val="solid"/>
+                      <a:round/>
+                      <a:headEnd type="none" w="med" len="med"/>
+                      <a:tailEnd type="none" w="med" len="med"/>
+                    </a:lnL>
+                    <a:lnR w="9525" cap="flat" cmpd="sng" algn="ctr">
+                      <a:solidFill>
+                        <a:srgbClr val="C9D1DB"/>
+                      </a:solidFill>
+                      <a:prstDash val="solid"/>
+                      <a:round/>
+                      <a:headEnd type="none" w="med" len="med"/>
+                      <a:tailEnd type="none" w="med" len="med"/>
+                    </a:lnR>
+                    <a:lnT w="9525" cap="flat" cmpd="sng" algn="ctr">
+                      <a:solidFill>
+                        <a:srgbClr val="C9D1DB"/>
+                      </a:solidFill>
+                      <a:prstDash val="solid"/>
+                      <a:round/>
+                      <a:headEnd type="none" w="med" len="med"/>
+                      <a:tailEnd type="none" w="med" len="med"/>
+                    </a:lnT>
+                    <a:lnB w="9525" cap="flat" cmpd="sng" algn="ctr">
+                      <a:solidFill>
+                        <a:srgbClr val="C9D1DB"/>
+                      </a:solidFill>
+                      <a:prstDash val="solid"/>
+                      <a:round/>
+                      <a:headEnd type="none" w="med" len="med"/>
+                      <a:tailEnd type="none" w="med" len="med"/>
+                    </a:lnB>
+                  </a:tcPr>
+                </a:tc>
+                <a:tc>
+                  <a:txBody>
+                    <a:bodyPr/>
+                    <a:lstStyle/>
+                    <a:p>
+                      <a:pPr indent="0" marL="0">
+                        <a:buNone/>
+                      </a:pPr>
+                      <a:r>
+                        <a:rPr lang="en-US" sz="1500" dirty="0">
+                          <a:solidFill>
+                            <a:srgbClr val="1B1F24"/>
+                          </a:solidFill>
+                        </a:rPr>
+                        <a:t>5</a:t>
+                      </a:r>
+                      <a:endParaRPr lang="en-US" sz="1500" dirty="0"/>
+                    </a:p>
+                  </a:txBody>
+                  <a:tcPr marL="73152" marR="73152" marT="73152" marB="73152">
+                    <a:lnL w="9525" cap="flat" cmpd="sng" algn="ctr">
+                      <a:solidFill>
+                        <a:srgbClr val="C9D1DB"/>
+                      </a:solidFill>
+                      <a:prstDash val="solid"/>
+                      <a:round/>
+                      <a:headEnd type="none" w="med" len="med"/>
+                      <a:tailEnd type="none" w="med" len="med"/>
+                    </a:lnL>
+                    <a:lnR w="9525" cap="flat" cmpd="sng" algn="ctr">
+                      <a:solidFill>
+                        <a:srgbClr val="C9D1DB"/>
+                      </a:solidFill>
+                      <a:prstDash val="solid"/>
+                      <a:round/>
+                      <a:headEnd type="none" w="med" len="med"/>
+                      <a:tailEnd type="none" w="med" len="med"/>
+                    </a:lnR>
+                    <a:lnT w="9525" cap="flat" cmpd="sng" algn="ctr">
+                      <a:solidFill>
+                        <a:srgbClr val="C9D1DB"/>
+                      </a:solidFill>
+                      <a:prstDash val="solid"/>
+                      <a:round/>
+                      <a:headEnd type="none" w="med" len="med"/>
+                      <a:tailEnd type="none" w="med" len="med"/>
+                    </a:lnT>
+                    <a:lnB w="9525" cap="flat" cmpd="sng" algn="ctr">
+                      <a:solidFill>
+                        <a:srgbClr val="C9D1DB"/>
+                      </a:solidFill>
+                      <a:prstDash val="solid"/>
+                      <a:round/>
+                      <a:headEnd type="none" w="med" len="med"/>
+                      <a:tailEnd type="none" w="med" len="med"/>
+                    </a:lnB>
+                  </a:tcPr>
+                </a:tc>
+                <a:tc>
+                  <a:txBody>
+                    <a:bodyPr/>
+                    <a:lstStyle/>
+                    <a:p>
+                      <a:pPr indent="0" marL="0">
+                        <a:buNone/>
+                      </a:pPr>
+                      <a:r>
+                        <a:rPr lang="en-US" sz="1500" dirty="0">
+                          <a:solidFill>
+                            <a:srgbClr val="1B1F24"/>
+                          </a:solidFill>
+                        </a:rPr>
+                        <a:t>6</a:t>
+                      </a:r>
+                      <a:endParaRPr lang="en-US" sz="1500" dirty="0"/>
+                    </a:p>
+                  </a:txBody>
+                  <a:tcPr marL="73152" marR="73152" marT="73152" marB="73152">
+                    <a:lnL w="9525" cap="flat" cmpd="sng" algn="ctr">
+                      <a:solidFill>
+                        <a:srgbClr val="C9D1DB"/>
+                      </a:solidFill>
+                      <a:prstDash val="solid"/>
+                      <a:round/>
+                      <a:headEnd type="none" w="med" len="med"/>
+                      <a:tailEnd type="none" w="med" len="med"/>
+                    </a:lnL>
+                    <a:lnR w="9525" cap="flat" cmpd="sng" algn="ctr">
+                      <a:solidFill>
+                        <a:srgbClr val="C9D1DB"/>
+                      </a:solidFill>
+                      <a:prstDash val="solid"/>
+                      <a:round/>
+                      <a:headEnd type="none" w="med" len="med"/>
+                      <a:tailEnd type="none" w="med" len="med"/>
+                    </a:lnR>
+                    <a:lnT w="9525" cap="flat" cmpd="sng" algn="ctr">
+                      <a:solidFill>
+                        <a:srgbClr val="C9D1DB"/>
+                      </a:solidFill>
+                      <a:prstDash val="solid"/>
+                      <a:round/>
+                      <a:headEnd type="none" w="med" len="med"/>
+                      <a:tailEnd type="none" w="med" len="med"/>
+                    </a:lnT>
+                    <a:lnB w="9525" cap="flat" cmpd="sng" algn="ctr">
+                      <a:solidFill>
+                        <a:srgbClr val="C9D1DB"/>
+                      </a:solidFill>
+                      <a:prstDash val="solid"/>
+                      <a:round/>
+                      <a:headEnd type="none" w="med" len="med"/>
+                      <a:tailEnd type="none" w="med" len="med"/>
+                    </a:lnB>
+                  </a:tcPr>
+                </a:tc>
+              </a:tr>
+              <a:tr h="502920">
+                <a:tc>
+                  <a:txBody>
+                    <a:bodyPr/>
+                    <a:lstStyle/>
+                    <a:p>
+                      <a:pPr indent="0" marL="0">
+                        <a:buNone/>
+                      </a:pPr>
+                      <a:r>
+                        <a:rPr lang="en-US" sz="1500" dirty="0">
+                          <a:solidFill>
+                            <a:srgbClr val="1B1F24"/>
+                          </a:solidFill>
+                        </a:rPr>
+                        <a:t>Performance (SRS targets)*</a:t>
                       </a:r>
                       <a:endParaRPr lang="en-US" sz="1500" dirty="0"/>
                     </a:p>
@@ -8834,7 +9158,7 @@
                             <a:srgbClr val="1B1F24"/>
                           </a:solidFill>
                         </a:rPr>
-                        <a:t>7</a:t>
+                        <a:t>6</a:t>
                       </a:r>
                       <a:endParaRPr lang="en-US" sz="1500" dirty="0"/>
                     </a:p>
@@ -8892,7 +9216,7 @@
                             <a:srgbClr val="1B1F24"/>
                           </a:solidFill>
                         </a:rPr>
-                        <a:t>0</a:t>
+                        <a:t>1</a:t>
                       </a:r>
                       <a:endParaRPr lang="en-US" sz="1500" dirty="0"/>
                     </a:p>
@@ -8984,7 +9308,7 @@
               <a:buChar char="•"/>
             </a:pPr>
             <a:r>
-              <a:rPr lang="en-US" sz="1400" dirty="0">
+              <a:rPr lang="en-US" sz="1300" dirty="0">
                 <a:solidFill>
                   <a:schemeClr val="tx1"/>
                 </a:solidFill>
@@ -9002,7 +9326,7 @@
               <a:buChar char="•"/>
             </a:pPr>
             <a:r>
-              <a:rPr lang="en-US" sz="1400" dirty="0">
+              <a:rPr lang="en-US" sz="1300" dirty="0">
                 <a:solidFill>
                   <a:schemeClr val="tx1"/>
                 </a:solidFill>
@@ -9020,7 +9344,7 @@
               <a:buChar char="•"/>
             </a:pPr>
             <a:r>
-              <a:rPr lang="en-US" sz="1400" dirty="0">
+              <a:rPr lang="en-US" sz="1300" dirty="0">
                 <a:solidFill>
                   <a:schemeClr val="tx1"/>
                 </a:solidFill>
@@ -9038,7 +9362,7 @@
               <a:buChar char="•"/>
             </a:pPr>
             <a:r>
-              <a:rPr lang="en-US" sz="1400" dirty="0">
+              <a:rPr lang="en-US" sz="1300" dirty="0">
                 <a:solidFill>
                   <a:schemeClr val="tx1"/>
                 </a:solidFill>
@@ -9056,7 +9380,7 @@
               <a:buChar char="•"/>
             </a:pPr>
             <a:r>
-              <a:rPr lang="en-US" sz="1400" dirty="0">
+              <a:rPr lang="en-US" sz="1300" dirty="0">
                 <a:solidFill>
                   <a:schemeClr val="tx1"/>
                 </a:solidFill>
@@ -9074,7 +9398,7 @@
               <a:buChar char="•"/>
             </a:pPr>
             <a:r>
-              <a:rPr lang="en-US" sz="1400" dirty="0">
+              <a:rPr lang="en-US" sz="1300" dirty="0">
                 <a:solidFill>
                   <a:schemeClr val="tx1"/>
                 </a:solidFill>
@@ -9092,7 +9416,7 @@
               <a:buChar char="•"/>
             </a:pPr>
             <a:r>
-              <a:rPr lang="en-US" sz="1400" dirty="0">
+              <a:rPr lang="en-US" sz="1300" dirty="0">
                 <a:solidFill>
                   <a:schemeClr val="tx1"/>
                 </a:solidFill>
@@ -9110,14 +9434,104 @@
               <a:buChar char="•"/>
             </a:pPr>
             <a:r>
-              <a:rPr lang="en-US" sz="1400" dirty="0">
+              <a:rPr lang="en-US" sz="1300" dirty="0">
                 <a:solidFill>
                   <a:schemeClr val="tx1"/>
                 </a:solidFill>
               </a:rPr>
-              <a:t>Each re-tested after the fix; full list in report Table 5.30</a:t>
+              <a:t>D14 Two C2LOP families had no MITRE mapping → added</a:t>
             </a:r>
             <a:endParaRPr lang="en-US" sz="1600" dirty="0"/>
+          </a:p>
+          <a:p>
+            <a:pPr marL="228600" indent="-228600">
+              <a:spcAft>
+                <a:spcPts val="600"/>
+              </a:spcAft>
+              <a:buSzPct val="100000"/>
+              <a:buChar char="•"/>
+            </a:pPr>
+            <a:r>
+              <a:rPr lang="en-US" sz="1300" dirty="0">
+                <a:solidFill>
+                  <a:schemeClr val="tx1"/>
+                </a:solidFill>
+              </a:rPr>
+              <a:t>D15 Tests overwrote the real class list → isolated</a:t>
+            </a:r>
+            <a:endParaRPr lang="en-US" sz="1600" dirty="0"/>
+          </a:p>
+          <a:p>
+            <a:pPr marL="228600" indent="-228600">
+              <a:spcAft>
+                <a:spcPts val="600"/>
+              </a:spcAft>
+              <a:buSzPct val="100000"/>
+              <a:buChar char="•"/>
+            </a:pPr>
+            <a:r>
+              <a:rPr lang="en-US" sz="1300" dirty="0">
+                <a:solidFill>
+                  <a:schemeClr val="tx1"/>
+                </a:solidFill>
+              </a:rPr>
+              <a:t>D16 History query 737 ms &gt; 500 ms → covering index, &lt; 10 ms</a:t>
+            </a:r>
+            <a:endParaRPr lang="en-US" sz="1600" dirty="0"/>
+          </a:p>
+          <a:p>
+            <a:pPr marL="228600" indent="-228600">
+              <a:spcAft>
+                <a:spcPts val="600"/>
+              </a:spcAft>
+              <a:buSzPct val="100000"/>
+              <a:buChar char="•"/>
+            </a:pPr>
+            <a:r>
+              <a:rPr lang="en-US" sz="1300" dirty="0">
+                <a:solidFill>
+                  <a:schemeClr val="tx1"/>
+                </a:solidFill>
+              </a:rPr>
+              <a:t>Full list in report Table 5.31</a:t>
+            </a:r>
+            <a:endParaRPr lang="en-US" sz="1600" dirty="0"/>
+          </a:p>
+        </p:txBody>
+      </p:sp>
+      <p:sp>
+        <p:nvSpPr>
+          <p:cNvPr id="5" name="Text 2"/>
+          <p:cNvSpPr txBox="1"/>
+          <p:nvPr/>
+        </p:nvSpPr>
+        <p:spPr>
+          <a:xfrm>
+            <a:off x="548640" y="5440680"/>
+            <a:ext cx="5394960" cy="365760"/>
+          </a:xfrm>
+          <a:prstGeom prst="rect">
+            <a:avLst/>
+          </a:prstGeom>
+          <a:noFill/>
+          <a:ln/>
+        </p:spPr>
+        <p:txBody>
+          <a:bodyPr wrap="square" lIns="0" tIns="0" rIns="0" bIns="0" rtlCol="0" anchor="t"/>
+          <a:lstStyle/>
+          <a:p>
+            <a:pPr indent="0" marL="0">
+              <a:buNone/>
+            </a:pPr>
+            <a:r>
+              <a:rPr lang="en-US" sz="1200" i="1" dirty="0">
+                <a:solidFill>
+                  <a:schemeClr val="tx2"/>
+                </a:solidFill>
+              </a:rPr>
+              <a:t>* First run on the laptop; all causes fixed, re-run before the demo</a:t>
+            </a:r>
+            <a:endParaRPr lang="en-US" sz="1200" dirty="0"/>
           </a:p>
         </p:txBody>
       </p:sp>
@@ -13483,7 +13897,7 @@
                   <a:schemeClr val="accent2"/>
                 </a:solidFill>
               </a:rPr>
-              <a:t>355</a:t>
+              <a:t>357</a:t>
             </a:r>
             <a:endParaRPr lang="en-US" sz="4400" dirty="0"/>
           </a:p>
@@ -17592,10 +18006,10 @@
             <a:r>
               <a:rPr lang="en-US" sz="3000" b="1" dirty="0">
                 <a:solidFill>
-                  <a:schemeClr val="accent3"/>
+                  <a:schemeClr val="accent1"/>
                 </a:solidFill>
               </a:rPr>
-              <a:t>[PENDING]</a:t>
+              <a:t>99.997%</a:t>
             </a:r>
             <a:endParaRPr lang="en-US" sz="3000" dirty="0"/>
           </a:p>
@@ -17631,7 +18045,7 @@
                   <a:schemeClr val="tx2"/>
                 </a:solidFill>
               </a:rPr>
-              <a:t>IoT-23 detection rate / FPR</a:t>
+              <a:t>IoT-23 malicious flows detected · 0.18% FPR (random split)</a:t>
             </a:r>
             <a:endParaRPr lang="en-US" sz="1400" dirty="0"/>
           </a:p>
@@ -17667,7 +18081,7 @@
                   <a:schemeClr val="tx2"/>
                 </a:solidFill>
               </a:rPr>
-              <a:t>Measured performance (2-core CPU): inference 26 ms · Grad-CAM 0.49 s · report 10 ms · 100k-row query 0.1 s, all within SRS limits</a:t>
+              <a:t>Measured on the demo laptop (8-core CPU, no GPU): inference 28 ms · Grad-CAM 0.51 s · report 38 ms · 10k-flow capture 0.32 s · all within SRS limits</a:t>
             </a:r>
             <a:endParaRPr lang="en-US" sz="1500" dirty="0"/>
           </a:p>
@@ -18075,8 +18489,8 @@
         </p:nvSpPr>
         <p:spPr>
           <a:xfrm>
-            <a:off x="640080" y="2743200"/>
-            <a:ext cx="10515600" cy="1005840"/>
+            <a:off x="548640" y="320040"/>
+            <a:ext cx="11064240" cy="777240"/>
           </a:xfrm>
           <a:prstGeom prst="rect">
             <a:avLst/>
@@ -18085,21 +18499,357 @@
           <a:ln/>
         </p:spPr>
         <p:txBody>
-          <a:bodyPr wrap="square" rtlCol="0"/>
+          <a:bodyPr wrap="square" rtlCol="0" anchor="ctr"/>
           <a:lstStyle/>
           <a:p>
-            <a:pPr algn="l" indent="0" marL="0">
+            <a:pPr indent="0" marL="0">
               <a:buNone/>
             </a:pPr>
             <a:r>
-              <a:rPr lang="en-US" sz="4000" b="1" dirty="0">
+              <a:rPr lang="en-US" sz="3200" b="1" dirty="0">
                 <a:solidFill>
-                  <a:schemeClr val="bg1"/>
+                  <a:schemeClr val="tx1"/>
                 </a:solidFill>
               </a:rPr>
-              <a:t>Next steps</a:t>
+              <a:t>On the dashboard: right, wrong and clean</a:t>
             </a:r>
-            <a:endParaRPr lang="en-US" sz="4000" dirty="0"/>
+            <a:endParaRPr lang="en-US" sz="3200" dirty="0"/>
+          </a:p>
+        </p:txBody>
+      </p:sp>
+      <p:pic>
+        <p:nvPicPr>
+          <p:cNvPr id="3" name="Image 0" descr="/tmp/claude-0/-home-claude-maltwin/b0d3e466-e30c-58b7-82f4-5b5331a1e75f/scratchpad/deck/ss_detect_ok.png">    </p:cNvPr>
+          <p:cNvPicPr>
+            <a:picLocks noChangeAspect="1"/>
+          </p:cNvPicPr>
+          <p:nvPr/>
+        </p:nvPicPr>
+        <p:blipFill>
+          <a:blip r:embed="rId1"/>
+          <a:stretch>
+            <a:fillRect/>
+          </a:stretch>
+        </p:blipFill>
+        <p:spPr>
+          <a:xfrm>
+            <a:off x="1135350" y="1280160"/>
+            <a:ext cx="4312980" cy="2240280"/>
+          </a:xfrm>
+          <a:prstGeom prst="rect">
+            <a:avLst/>
+          </a:prstGeom>
+        </p:spPr>
+      </p:pic>
+      <p:sp>
+        <p:nvSpPr>
+          <p:cNvPr id="4" name="Text 1"/>
+          <p:cNvSpPr txBox="1"/>
+          <p:nvPr/>
+        </p:nvSpPr>
+        <p:spPr>
+          <a:xfrm>
+            <a:off x="548640" y="3547872"/>
+            <a:ext cx="5486400" cy="292608"/>
+          </a:xfrm>
+          <a:prstGeom prst="rect">
+            <a:avLst/>
+          </a:prstGeom>
+          <a:noFill/>
+          <a:ln/>
+        </p:spPr>
+        <p:txBody>
+          <a:bodyPr wrap="square" lIns="0" tIns="0" rIns="0" bIns="0" rtlCol="0" anchor="t"/>
+          <a:lstStyle/>
+          <a:p>
+            <a:pPr algn="ctr" indent="0" marL="0">
+              <a:buNone/>
+            </a:pPr>
+            <a:r>
+              <a:rPr lang="en-US" sz="1200" dirty="0">
+                <a:solidFill>
+                  <a:schemeClr val="accent5"/>
+                </a:solidFill>
+              </a:rPr>
+              <a:t>Held-out Adialer.C test image → correct, 100%</a:t>
+            </a:r>
+            <a:endParaRPr lang="en-US" sz="1200" dirty="0"/>
+          </a:p>
+        </p:txBody>
+      </p:sp>
+      <p:pic>
+        <p:nvPicPr>
+          <p:cNvPr id="5" name="Image 1" descr="/tmp/claude-0/-home-claude-maltwin/b0d3e466-e30c-58b7-82f4-5b5331a1e75f/scratchpad/deck/ss_detect_wrong.png">    </p:cNvPr>
+          <p:cNvPicPr>
+            <a:picLocks noChangeAspect="1"/>
+          </p:cNvPicPr>
+          <p:nvPr/>
+        </p:nvPicPr>
+        <p:blipFill>
+          <a:blip r:embed="rId2"/>
+          <a:stretch>
+            <a:fillRect/>
+          </a:stretch>
+        </p:blipFill>
+        <p:spPr>
+          <a:xfrm>
+            <a:off x="7101071" y="1280160"/>
+            <a:ext cx="3628658" cy="2240280"/>
+          </a:xfrm>
+          <a:prstGeom prst="rect">
+            <a:avLst/>
+          </a:prstGeom>
+        </p:spPr>
+      </p:pic>
+      <p:sp>
+        <p:nvSpPr>
+          <p:cNvPr id="6" name="Text 2"/>
+          <p:cNvSpPr txBox="1"/>
+          <p:nvPr/>
+        </p:nvSpPr>
+        <p:spPr>
+          <a:xfrm>
+            <a:off x="6172200" y="3547872"/>
+            <a:ext cx="5486400" cy="292608"/>
+          </a:xfrm>
+          <a:prstGeom prst="rect">
+            <a:avLst/>
+          </a:prstGeom>
+          <a:noFill/>
+          <a:ln/>
+        </p:spPr>
+        <p:txBody>
+          <a:bodyPr wrap="square" lIns="0" tIns="0" rIns="0" bIns="0" rtlCol="0" anchor="t"/>
+          <a:lstStyle/>
+          <a:p>
+            <a:pPr algn="ctr" indent="0" marL="0">
+              <a:buNone/>
+            </a:pPr>
+            <a:r>
+              <a:rPr lang="en-US" sz="1200" dirty="0">
+                <a:solidFill>
+                  <a:schemeClr val="accent5"/>
+                </a:solidFill>
+              </a:rPr>
+              <a:t>Swizzor.gen!I → called Swizzor.gen!E (right family, wrong variant)</a:t>
+            </a:r>
+            <a:endParaRPr lang="en-US" sz="1200" dirty="0"/>
+          </a:p>
+        </p:txBody>
+      </p:sp>
+      <p:pic>
+        <p:nvPicPr>
+          <p:cNvPr id="7" name="Image 2" descr="/tmp/claude-0/-home-claude-maltwin/b0d3e466-e30c-58b7-82f4-5b5331a1e75f/scratchpad/deck/ss_benign.png">    </p:cNvPr>
+          <p:cNvPicPr>
+            <a:picLocks noChangeAspect="1"/>
+          </p:cNvPicPr>
+          <p:nvPr/>
+        </p:nvPicPr>
+        <p:blipFill>
+          <a:blip r:embed="rId3"/>
+          <a:stretch>
+            <a:fillRect/>
+          </a:stretch>
+        </p:blipFill>
+        <p:spPr>
+          <a:xfrm>
+            <a:off x="1965781" y="3886200"/>
+            <a:ext cx="2652117" cy="1600200"/>
+          </a:xfrm>
+          <a:prstGeom prst="rect">
+            <a:avLst/>
+          </a:prstGeom>
+        </p:spPr>
+      </p:pic>
+      <p:sp>
+        <p:nvSpPr>
+          <p:cNvPr id="8" name="Text 3"/>
+          <p:cNvSpPr txBox="1"/>
+          <p:nvPr/>
+        </p:nvSpPr>
+        <p:spPr>
+          <a:xfrm>
+            <a:off x="548640" y="5513832"/>
+            <a:ext cx="5486400" cy="292608"/>
+          </a:xfrm>
+          <a:prstGeom prst="rect">
+            <a:avLst/>
+          </a:prstGeom>
+          <a:noFill/>
+          <a:ln/>
+        </p:spPr>
+        <p:txBody>
+          <a:bodyPr wrap="square" lIns="0" tIns="0" rIns="0" bIns="0" rtlCol="0" anchor="t"/>
+          <a:lstStyle/>
+          <a:p>
+            <a:pPr algn="ctr" indent="0" marL="0">
+              <a:buNone/>
+            </a:pPr>
+            <a:r>
+              <a:rPr lang="en-US" sz="1200" dirty="0">
+                <a:solidFill>
+                  <a:schemeClr val="accent5"/>
+                </a:solidFill>
+              </a:rPr>
+              <a:t>Clean clang64.exe → Benign, 99.5%</a:t>
+            </a:r>
+            <a:endParaRPr lang="en-US" sz="1200" dirty="0"/>
+          </a:p>
+        </p:txBody>
+      </p:sp>
+      <p:pic>
+        <p:nvPicPr>
+          <p:cNvPr id="9" name="Image 3" descr="/tmp/claude-0/-home-claude-maltwin/b0d3e466-e30c-58b7-82f4-5b5331a1e75f/scratchpad/deck/ss_dynamic.png">    </p:cNvPr>
+          <p:cNvPicPr>
+            <a:picLocks noChangeAspect="1"/>
+          </p:cNvPicPr>
+          <p:nvPr/>
+        </p:nvPicPr>
+        <p:blipFill>
+          <a:blip r:embed="rId4"/>
+          <a:stretch>
+            <a:fillRect/>
+          </a:stretch>
+        </p:blipFill>
+        <p:spPr>
+          <a:xfrm>
+            <a:off x="7422419" y="3886200"/>
+            <a:ext cx="2985961" cy="1600200"/>
+          </a:xfrm>
+          <a:prstGeom prst="rect">
+            <a:avLst/>
+          </a:prstGeom>
+        </p:spPr>
+      </p:pic>
+      <p:sp>
+        <p:nvSpPr>
+          <p:cNvPr id="10" name="Text 4"/>
+          <p:cNvSpPr txBox="1"/>
+          <p:nvPr/>
+        </p:nvSpPr>
+        <p:spPr>
+          <a:xfrm>
+            <a:off x="6172200" y="5513832"/>
+            <a:ext cx="5486400" cy="292608"/>
+          </a:xfrm>
+          <a:prstGeom prst="rect">
+            <a:avLst/>
+          </a:prstGeom>
+          <a:noFill/>
+          <a:ln/>
+        </p:spPr>
+        <p:txBody>
+          <a:bodyPr wrap="square" lIns="0" tIns="0" rIns="0" bIns="0" rtlCol="0" anchor="t"/>
+          <a:lstStyle/>
+          <a:p>
+            <a:pPr algn="ctr" indent="0" marL="0">
+              <a:buNone/>
+            </a:pPr>
+            <a:r>
+              <a:rPr lang="en-US" sz="1200" dirty="0">
+                <a:solidFill>
+                  <a:schemeClr val="accent5"/>
+                </a:solidFill>
+              </a:rPr>
+              <a:t>Dynamic model on IoT-23: 100% detection, 0.2% FPR</a:t>
+            </a:r>
+            <a:endParaRPr lang="en-US" sz="1200" dirty="0"/>
+          </a:p>
+        </p:txBody>
+      </p:sp>
+      <p:sp>
+        <p:nvSpPr>
+          <p:cNvPr id="11" name="Shape 5"/>
+          <p:cNvSpPr/>
+          <p:nvPr/>
+        </p:nvSpPr>
+        <p:spPr>
+          <a:xfrm>
+            <a:off x="548640" y="5852160"/>
+            <a:ext cx="457200" cy="457200"/>
+          </a:xfrm>
+          <a:prstGeom prst="ellipse">
+            <a:avLst/>
+          </a:prstGeom>
+          <a:solidFill>
+            <a:schemeClr val="accent3"/>
+          </a:solidFill>
+          <a:ln w="12700">
+            <a:solidFill>
+              <a:schemeClr val="accent3"/>
+            </a:solidFill>
+            <a:prstDash val="solid"/>
+          </a:ln>
+        </p:spPr>
+      </p:sp>
+      <p:pic>
+        <p:nvPicPr>
+          <p:cNvPr id="12" name="Image 4" descr="preencoded.png">    </p:cNvPr>
+          <p:cNvPicPr>
+            <a:picLocks noChangeAspect="1"/>
+          </p:cNvPicPr>
+          <p:nvPr/>
+        </p:nvPicPr>
+        <p:blipFill>
+          <a:blip r:embed="rId5"/>
+          <a:stretch>
+            <a:fillRect/>
+          </a:stretch>
+        </p:blipFill>
+        <p:spPr>
+          <a:xfrm>
+            <a:off x="649224" y="5952744"/>
+            <a:ext cx="256032" cy="256032"/>
+          </a:xfrm>
+          <a:prstGeom prst="rect">
+            <a:avLst/>
+          </a:prstGeom>
+        </p:spPr>
+      </p:pic>
+      <p:sp>
+        <p:nvSpPr>
+          <p:cNvPr id="13" name="Text 6"/>
+          <p:cNvSpPr txBox="1"/>
+          <p:nvPr/>
+        </p:nvSpPr>
+        <p:spPr>
+          <a:xfrm>
+            <a:off x="1143000" y="5925312"/>
+            <a:ext cx="10058400" cy="365760"/>
+          </a:xfrm>
+          <a:prstGeom prst="rect">
+            <a:avLst/>
+          </a:prstGeom>
+          <a:noFill/>
+          <a:ln/>
+        </p:spPr>
+        <p:txBody>
+          <a:bodyPr wrap="square" lIns="0" tIns="0" rIns="0" bIns="0" rtlCol="0" anchor="t"/>
+          <a:lstStyle/>
+          <a:p>
+            <a:pPr indent="0" marL="0">
+              <a:buNone/>
+            </a:pPr>
+            <a:r>
+              <a:rPr lang="en-US" sz="1500" b="1" dirty="0">
+                <a:solidFill>
+                  <a:schemeClr val="accent3"/>
+                </a:solidFill>
+              </a:rPr>
+              <a:t>LIVE DEMO  </a:t>
+            </a:r>
+            <a:pPr indent="0" marL="0">
+              <a:buNone/>
+            </a:pPr>
+            <a:r>
+              <a:rPr lang="en-US" sz="1500" dirty="0">
+                <a:solidFill>
+                  <a:schemeClr val="tx1"/>
+                </a:solidFill>
+              </a:rPr>
+              <a:t>Binary Upload → "Malimg test-set sample" tab → Load → Run Detection (ground truth shown)</a:t>
+            </a:r>
+            <a:endParaRPr lang="en-US" sz="1500" dirty="0"/>
           </a:p>
         </p:txBody>
       </p:sp>
@@ -18183,6 +18933,114 @@
         </p:nvSpPr>
         <p:spPr>
           <a:xfrm>
+            <a:off x="640080" y="2743200"/>
+            <a:ext cx="10515600" cy="1005840"/>
+          </a:xfrm>
+          <a:prstGeom prst="rect">
+            <a:avLst/>
+          </a:prstGeom>
+          <a:noFill/>
+          <a:ln/>
+        </p:spPr>
+        <p:txBody>
+          <a:bodyPr wrap="square" rtlCol="0"/>
+          <a:lstStyle/>
+          <a:p>
+            <a:pPr algn="l" indent="0" marL="0">
+              <a:buNone/>
+            </a:pPr>
+            <a:r>
+              <a:rPr lang="en-US" sz="4000" b="1" dirty="0">
+                <a:solidFill>
+                  <a:schemeClr val="bg1"/>
+                </a:solidFill>
+              </a:rPr>
+              <a:t>Next steps</a:t>
+            </a:r>
+            <a:endParaRPr lang="en-US" sz="4000" dirty="0"/>
+          </a:p>
+        </p:txBody>
+      </p:sp>
+      <p:sp>
+        <p:nvSpPr>
+          <p:cNvPr id="25" name="Slide Number Placeholder 0"/>
+          <p:cNvSpPr>
+            <a:spLocks noGrp="1"/>
+          </p:cNvSpPr>
+          <p:nvPr>
+            <p:ph type="sldNum" sz="quarter" idx="4294967295"/>
+          </p:nvPr>
+        </p:nvSpPr>
+        <p:spPr>
+          <a:xfrm>
+            <a:off x="11338560" y="6355080"/>
+            <a:ext cx="548640" cy="320040"/>
+          </a:xfrm>
+          <a:prstGeom prst="rect">
+            <a:avLst/>
+          </a:prstGeom>
+          <a:extLst>
+            <a:ext uri="{C572A759-6A51-4108-AA02-DFA0A04FC94B}">
+              <ma14:wrappingTextBoxFlag xmlns:ma14="http://schemas.microsoft.com/office/mac/drawingml/2011/main" val="0"/>
+            </a:ext>
+          </a:extLst>
+        </p:spPr>
+        <p:txBody>
+          <a:bodyPr/>
+          <a:lstStyle>
+            <a:lvl1pPr>
+              <a:defRPr sz="1100">
+                <a:solidFill>
+                  <a:schemeClr val="accent5"/>
+                </a:solidFill>
+              </a:defRPr>
+            </a:lvl1pPr>
+          </a:lstStyle>
+          <a:p>
+            <a:pPr algn="l"/>
+            <a:fld id="{F7021451-1387-4CA6-816F-3879F97B5CBC}" type="slidenum">
+              <a:rPr b="0" lang="en-US"/>
+              <a:t>27</a:t>
+            </a:fld>
+            <a:endParaRPr lang="en-US"/>
+          </a:p>
+        </p:txBody>
+      </p:sp>
+    </p:spTree>
+  </p:cSld>
+  <p:clrMapOvr>
+    <a:masterClrMapping/>
+  </p:clrMapOvr>
+</p:sld>
+</file>
+
+<file path=ppt/slides/slide28.xml><?xml version="1.0" encoding="utf-8"?>
+<p:sld xmlns:a="http://schemas.openxmlformats.org/drawingml/2006/main" xmlns:r="http://schemas.openxmlformats.org/officeDocument/2006/relationships" xmlns:p="http://schemas.openxmlformats.org/presentationml/2006/main">
+  <p:cSld name="Slide 28">
+    <p:spTree>
+      <p:nvGrpSpPr>
+        <p:cNvPr id="1" name=""/>
+        <p:cNvGrpSpPr/>
+        <p:nvPr/>
+      </p:nvGrpSpPr>
+      <p:grpSpPr>
+        <a:xfrm>
+          <a:off x="0" y="0"/>
+          <a:ext cx="0" cy="0"/>
+          <a:chOff x="0" y="0"/>
+          <a:chExt cx="0" cy="0"/>
+        </a:xfrm>
+      </p:grpSpPr>
+      <p:sp>
+        <p:nvSpPr>
+          <p:cNvPr id="2" name="Text 0"/>
+          <p:cNvSpPr/>
+          <p:nvPr>
+            <p:ph idx="100" type="title" hasCustomPrompt="1"/>
+          </p:nvPr>
+        </p:nvSpPr>
+        <p:spPr>
+          <a:xfrm>
             <a:off x="548640" y="320040"/>
             <a:ext cx="11064240" cy="777240"/>
           </a:xfrm>
@@ -18848,7 +19706,7 @@
             <a:pPr algn="l"/>
             <a:fld id="{F7021451-1387-4CA6-816F-3879F97B5CBC}" type="slidenum">
               <a:rPr b="0" lang="en-US"/>
-              <a:t>27</a:t>
+              <a:t>28</a:t>
             </a:fld>
             <a:endParaRPr lang="en-US"/>
           </a:p>
@@ -18862,9 +19720,9 @@
 </p:sld>
 </file>
 
-<file path=ppt/slides/slide28.xml><?xml version="1.0" encoding="utf-8"?>
+<file path=ppt/slides/slide29.xml><?xml version="1.0" encoding="utf-8"?>
 <p:sld xmlns:a="http://schemas.openxmlformats.org/drawingml/2006/main" xmlns:r="http://schemas.openxmlformats.org/officeDocument/2006/relationships" xmlns:p="http://schemas.openxmlformats.org/presentationml/2006/main">
-  <p:cSld name="Slide 28">
+  <p:cSld name="Slide 29">
     <p:spTree>
       <p:nvGrpSpPr>
         <p:cNvPr id="1" name=""/>
@@ -24606,7 +25464,7 @@
                   <a:schemeClr val="tx2"/>
                 </a:solidFill>
               </a:rPr>
-              <a:t>355 automated tests, all passing; 78 tagged tests cover 57 / 57 testable requirements</a:t>
+              <a:t>357 automated tests, all passing; 79 tagged tests cover 57 / 57 testable requirements</a:t>
             </a:r>
             <a:endParaRPr lang="en-US" sz="1400" dirty="0"/>
           </a:p>

</xml_diff>

<commit_message>
Deck: fix stale module facts (augmentation off, 17 defects, behaviour taxonomy)
Co-Authored-By: Claude Opus 5.5 <noreply@anthropic.com>
Claude-Session: https://claude.ai/code/session_015h4SwWvXQGuvs9F8VqDPvi
</commit_message>
<xml_diff>
--- a/docs/MalTwin_60pct_Evaluation.pptx
+++ b/docs/MalTwin_60pct_Evaluation.pptx
@@ -135,17 +135,17 @@
   <p:extLst>
     <p:ext uri="{521415D9-36F7-43E2-AB2F-B90AF26B5E84}">
       <p14:sectionLst xmlns:p14="http://schemas.microsoft.com/office/powerpoint/2010/main">
-        <p14:section name="Title" id="{8553df1e-d3b6-35bb-4d96-dc23c70685b7}">
+        <p14:section name="Title" id="{10a7d47e-ef0b-8ea9-d269-c0a339f57a45}">
           <p14:sldIdLst>
             <p14:sldId id="256"/>
           </p14:sldIdLst>
         </p14:section>
-        <p14:section name="Introduction" id="{e6beafc7-318a-f643-e73f-bd3982b988a5}">
+        <p14:section name="Introduction" id="{e3ddd653-ebad-53be-ae4e-2ec337b6880f}">
           <p14:sldIdLst>
             <p14:sldId id="257"/>
           </p14:sldIdLst>
         </p14:section>
-        <p14:section name="Changes since 30%" id="{723565f1-d06a-a557-f8db-12032674ee62}">
+        <p14:section name="Changes since 30%" id="{a1037141-0ea4-6e7c-dcfa-9b429ab3501b}">
           <p14:sldIdLst>
             <p14:sldId id="258"/>
             <p14:sldId id="259"/>
@@ -154,7 +154,7 @@
             <p14:sldId id="262"/>
           </p14:sldIdLst>
         </p14:section>
-        <p14:section name="Implemented modules" id="{38e0f0bd-cc50-97da-790e-d35f5084a1a6}">
+        <p14:section name="Implemented modules" id="{5f044ab3-ead1-a728-2409-60a49463f2a7}">
           <p14:sldIdLst>
             <p14:sldId id="263"/>
             <p14:sldId id="264"/>
@@ -164,14 +164,14 @@
             <p14:sldId id="268"/>
           </p14:sldIdLst>
         </p14:section>
-        <p14:section name="Testing" id="{4bac3380-1da5-4f3c-5665-e9fe5c4c227b}">
+        <p14:section name="Testing" id="{7af5f468-83e0-029a-9f16-0d1468a42a44}">
           <p14:sldIdLst>
             <p14:sldId id="269"/>
             <p14:sldId id="270"/>
             <p14:sldId id="271"/>
           </p14:sldIdLst>
         </p14:section>
-        <p14:section name="Automated testing" id="{25e86322-3987-8b78-3d32-faf71336154d}">
+        <p14:section name="Automated testing" id="{06ef9e4b-c826-6ab9-0272-4ab5957eda5c}">
           <p14:sldIdLst>
             <p14:sldId id="272"/>
             <p14:sldId id="273"/>
@@ -180,7 +180,7 @@
             <p14:sldId id="276"/>
           </p14:sldIdLst>
         </p14:section>
-        <p14:section name="AI / ML techniques" id="{ba898fd5-26f8-d34e-3b9a-7e1e1d795218}">
+        <p14:section name="AI / ML techniques" id="{297d8eca-d3cb-24fc-210c-1779de08c99c}">
           <p14:sldIdLst>
             <p14:sldId id="277"/>
             <p14:sldId id="278"/>
@@ -189,13 +189,13 @@
             <p14:sldId id="281"/>
           </p14:sldIdLst>
         </p14:section>
-        <p14:section name="Next steps" id="{c53165cc-b70c-3a6f-2b52-09fd15c00654}">
+        <p14:section name="Next steps" id="{80ba95c4-980e-4510-9b1e-7d38a91daf38}">
           <p14:sldIdLst>
             <p14:sldId id="282"/>
             <p14:sldId id="283"/>
           </p14:sldIdLst>
         </p14:section>
-        <p14:section name="Close" id="{fa28578d-68d0-1ce4-ce5b-d41adb479799}">
+        <p14:section name="Close" id="{b3f545ff-86c1-8581-e478-e586b98d0470}">
           <p14:sldIdLst>
             <p14:sldId id="284"/>
           </p14:sldIdLst>
@@ -4675,7 +4675,7 @@
                   <a:schemeClr val="tx1"/>
                 </a:solidFill>
               </a:rPr>
-              <a:t>Rotation, flip, brightness, noise</a:t>
+              <a:t>Augmentation built, off by default (ablation)</a:t>
             </a:r>
             <a:endParaRPr lang="en-US" sz="1400" dirty="0"/>
           </a:p>
@@ -5069,7 +5069,7 @@
                   <a:schemeClr val="tx1"/>
                 </a:solidFill>
               </a:rPr>
-              <a:t>Random forest, 7 behaviours</a:t>
+              <a:t>Random forest, 7-behaviour taxonomy</a:t>
             </a:r>
             <a:endParaRPr lang="en-US" sz="1400" dirty="0"/>
           </a:p>
@@ -25132,7 +25132,7 @@
                   <a:schemeClr val="tx1"/>
                 </a:solidFill>
               </a:rPr>
-              <a:t>13 defects fixed</a:t>
+              <a:t>17 defects fixed</a:t>
             </a:r>
             <a:endParaRPr lang="en-US" sz="1700" dirty="0"/>
           </a:p>
@@ -25168,7 +25168,7 @@
                   <a:schemeClr val="tx2"/>
                 </a:solidFill>
               </a:rPr>
-              <a:t>Crash after every upload, lost navigation clicks, reports never linked to their detection, and more</a:t>
+              <a:t>Crash after every upload, lost navigation clicks, reports never linked to their detection, a slow history query, and more</a:t>
             </a:r>
             <a:endParaRPr lang="en-US" sz="1400" dirty="0"/>
           </a:p>
@@ -26432,7 +26432,7 @@
                   <a:schemeClr val="tx1"/>
                 </a:solidFill>
               </a:rPr>
-              <a:t>MITRE ATT&amp;CK for ICS, 25/25 families</a:t>
+              <a:t>MITRE ATT&amp;CK for ICS, all 25 families</a:t>
             </a:r>
             <a:endParaRPr lang="en-US" sz="1400" dirty="0"/>
           </a:p>

</xml_diff>